<commit_message>
Audit fix: align code/data/figures/docs across Python/MATLAB/paper
- Irradiance model: OU process (tau=1s, sigma=25%), aerosol x0.93, July peak 744 W/m2
- LSTM: deterministic seed 42, 4-unit gain scheduler (101 params), 4,385 total
- New metrics: R2=0.835, MAE=54.7, RMSE=72.6 (OU data more realistic, thus lower)
- TFLite: Flex ops fallback for ESP32-S3 (TensorListReserve compat)
- MATLAB ha_artemis_v3: float 13.8V, 3-stage charging; ha_battery_v3: 6A bulk limit
- Python controllers: 15% blend deadband, [0.20,0.55] alpha plateau
- MOSFET IRFZ44N->IRFB4110 across all docs, figs, presentations
- Study guides, highlights, cover letter: N=200->30, 7,900-8,500->~1,500 BDT
- All 9 figures regenerated at 300 DPI, manuscript PDF rebuilt
</commit_message>
<xml_diff>
--- a/Docs/Presentation/Helios_Artemis_Detailed.pptx
+++ b/Docs/Presentation/Helios_Artemis_Detailed.pptx
@@ -1787,6 +1787,10 @@
             <a:prstDash val="solid"/>
           </a:ln>
         </p:spPr>
+        <p:txBody>
+          <a:bodyPr/>
+          <a:p/>
+        </p:txBody>
       </p:sp>
       <p:sp>
         <p:nvSpPr>
@@ -1812,6 +1816,10 @@
             <a:prstDash val="solid"/>
           </a:ln>
         </p:spPr>
+        <p:txBody>
+          <a:bodyPr/>
+          <a:p/>
+        </p:txBody>
       </p:sp>
       <p:sp>
         <p:nvSpPr>
@@ -1954,6 +1962,10 @@
             <a:prstDash val="solid"/>
           </a:ln>
         </p:spPr>
+        <p:txBody>
+          <a:bodyPr/>
+          <a:p/>
+        </p:txBody>
       </p:sp>
       <p:sp>
         <p:nvSpPr>
@@ -2018,6 +2030,10 @@
             <a:prstDash val="solid"/>
           </a:ln>
         </p:spPr>
+        <p:txBody>
+          <a:bodyPr/>
+          <a:p/>
+        </p:txBody>
       </p:sp>
       <p:sp>
         <p:nvSpPr>
@@ -2121,6 +2137,10 @@
             <a:prstDash val="solid"/>
           </a:ln>
         </p:spPr>
+        <p:txBody>
+          <a:bodyPr/>
+          <a:p/>
+        </p:txBody>
       </p:sp>
       <p:sp>
         <p:nvSpPr>
@@ -2224,6 +2244,10 @@
             <a:prstDash val="solid"/>
           </a:ln>
         </p:spPr>
+        <p:txBody>
+          <a:bodyPr/>
+          <a:p/>
+        </p:txBody>
       </p:sp>
       <p:sp>
         <p:nvSpPr>
@@ -2327,6 +2351,10 @@
             <a:prstDash val="solid"/>
           </a:ln>
         </p:spPr>
+        <p:txBody>
+          <a:bodyPr/>
+          <a:p/>
+        </p:txBody>
       </p:sp>
       <p:sp>
         <p:nvSpPr>
@@ -2499,6 +2527,10 @@
             <a:prstDash val="solid"/>
           </a:ln>
         </p:spPr>
+        <p:txBody>
+          <a:bodyPr/>
+          <a:p/>
+        </p:txBody>
       </p:sp>
       <p:sp>
         <p:nvSpPr>
@@ -2638,6 +2670,10 @@
             <a:prstDash val="solid"/>
           </a:ln>
         </p:spPr>
+        <p:txBody>
+          <a:bodyPr/>
+          <a:p/>
+        </p:txBody>
       </p:sp>
       <p:sp>
         <p:nvSpPr>
@@ -2670,6 +2706,10 @@
             </a:outerShdw>
           </a:effectLst>
         </p:spPr>
+        <p:txBody>
+          <a:bodyPr/>
+          <a:p/>
+        </p:txBody>
       </p:sp>
       <p:sp>
         <p:nvSpPr>
@@ -2695,6 +2735,10 @@
             <a:prstDash val="solid"/>
           </a:ln>
         </p:spPr>
+        <p:txBody>
+          <a:bodyPr/>
+          <a:p/>
+        </p:txBody>
       </p:sp>
       <p:sp>
         <p:nvSpPr>
@@ -2720,6 +2764,10 @@
             <a:prstDash val="solid"/>
           </a:ln>
         </p:spPr>
+        <p:txBody>
+          <a:bodyPr/>
+          <a:p/>
+        </p:txBody>
       </p:sp>
       <p:sp>
         <p:nvSpPr>
@@ -2869,6 +2917,10 @@
             </a:outerShdw>
           </a:effectLst>
         </p:spPr>
+        <p:txBody>
+          <a:bodyPr/>
+          <a:p/>
+        </p:txBody>
       </p:sp>
       <p:sp>
         <p:nvSpPr>
@@ -2894,6 +2946,10 @@
             <a:prstDash val="solid"/>
           </a:ln>
         </p:spPr>
+        <p:txBody>
+          <a:bodyPr/>
+          <a:p/>
+        </p:txBody>
       </p:sp>
       <p:sp>
         <p:nvSpPr>
@@ -2919,6 +2975,10 @@
             <a:prstDash val="solid"/>
           </a:ln>
         </p:spPr>
+        <p:txBody>
+          <a:bodyPr/>
+          <a:p/>
+        </p:txBody>
       </p:sp>
       <p:sp>
         <p:nvSpPr>
@@ -3068,6 +3128,10 @@
             </a:outerShdw>
           </a:effectLst>
         </p:spPr>
+        <p:txBody>
+          <a:bodyPr/>
+          <a:p/>
+        </p:txBody>
       </p:sp>
       <p:sp>
         <p:nvSpPr>
@@ -3093,6 +3157,10 @@
             <a:prstDash val="solid"/>
           </a:ln>
         </p:spPr>
+        <p:txBody>
+          <a:bodyPr/>
+          <a:p/>
+        </p:txBody>
       </p:sp>
       <p:sp>
         <p:nvSpPr>
@@ -3118,6 +3186,10 @@
             <a:prstDash val="solid"/>
           </a:ln>
         </p:spPr>
+        <p:txBody>
+          <a:bodyPr/>
+          <a:p/>
+        </p:txBody>
       </p:sp>
       <p:sp>
         <p:nvSpPr>
@@ -3267,6 +3339,10 @@
             </a:outerShdw>
           </a:effectLst>
         </p:spPr>
+        <p:txBody>
+          <a:bodyPr/>
+          <a:p/>
+        </p:txBody>
       </p:sp>
       <p:sp>
         <p:nvSpPr>
@@ -3292,6 +3368,10 @@
             <a:prstDash val="solid"/>
           </a:ln>
         </p:spPr>
+        <p:txBody>
+          <a:bodyPr/>
+          <a:p/>
+        </p:txBody>
       </p:sp>
       <p:sp>
         <p:nvSpPr>
@@ -3317,6 +3397,10 @@
             <a:prstDash val="solid"/>
           </a:ln>
         </p:spPr>
+        <p:txBody>
+          <a:bodyPr/>
+          <a:p/>
+        </p:txBody>
       </p:sp>
       <p:sp>
         <p:nvSpPr>
@@ -3466,6 +3550,10 @@
             </a:outerShdw>
           </a:effectLst>
         </p:spPr>
+        <p:txBody>
+          <a:bodyPr/>
+          <a:p/>
+        </p:txBody>
       </p:sp>
       <p:sp>
         <p:nvSpPr>
@@ -3491,6 +3579,10 @@
             <a:prstDash val="solid"/>
           </a:ln>
         </p:spPr>
+        <p:txBody>
+          <a:bodyPr/>
+          <a:p/>
+        </p:txBody>
       </p:sp>
       <p:sp>
         <p:nvSpPr>
@@ -3516,6 +3608,10 @@
             <a:prstDash val="solid"/>
           </a:ln>
         </p:spPr>
+        <p:txBody>
+          <a:bodyPr/>
+          <a:p/>
+        </p:txBody>
       </p:sp>
       <p:sp>
         <p:nvSpPr>
@@ -3665,6 +3761,10 @@
             </a:outerShdw>
           </a:effectLst>
         </p:spPr>
+        <p:txBody>
+          <a:bodyPr/>
+          <a:p/>
+        </p:txBody>
       </p:sp>
       <p:sp>
         <p:nvSpPr>
@@ -3690,6 +3790,10 @@
             <a:prstDash val="solid"/>
           </a:ln>
         </p:spPr>
+        <p:txBody>
+          <a:bodyPr/>
+          <a:p/>
+        </p:txBody>
       </p:sp>
       <p:sp>
         <p:nvSpPr>
@@ -3715,6 +3819,10 @@
             <a:prstDash val="solid"/>
           </a:ln>
         </p:spPr>
+        <p:txBody>
+          <a:bodyPr/>
+          <a:p/>
+        </p:txBody>
       </p:sp>
       <p:sp>
         <p:nvSpPr>
@@ -3857,6 +3965,10 @@
             <a:prstDash val="solid"/>
           </a:ln>
         </p:spPr>
+        <p:txBody>
+          <a:bodyPr/>
+          <a:p/>
+        </p:txBody>
       </p:sp>
       <p:sp>
         <p:nvSpPr>
@@ -4001,6 +4113,10 @@
             <a:prstDash val="solid"/>
           </a:ln>
         </p:spPr>
+        <p:txBody>
+          <a:bodyPr/>
+          <a:p/>
+        </p:txBody>
       </p:sp>
       <p:sp>
         <p:nvSpPr>
@@ -4140,6 +4256,10 @@
             <a:prstDash val="solid"/>
           </a:ln>
         </p:spPr>
+        <p:txBody>
+          <a:bodyPr/>
+          <a:p/>
+        </p:txBody>
       </p:sp>
       <p:sp>
         <p:nvSpPr>
@@ -4165,6 +4285,10 @@
             <a:prstDash val="solid"/>
           </a:ln>
         </p:spPr>
+        <p:txBody>
+          <a:bodyPr/>
+          <a:p/>
+        </p:txBody>
       </p:sp>
       <p:sp>
         <p:nvSpPr>
@@ -4190,6 +4314,10 @@
             <a:prstDash val="solid"/>
           </a:ln>
         </p:spPr>
+        <p:txBody>
+          <a:bodyPr/>
+          <a:p/>
+        </p:txBody>
       </p:sp>
       <p:sp>
         <p:nvSpPr>
@@ -4293,6 +4421,10 @@
             <a:prstDash val="solid"/>
           </a:ln>
         </p:spPr>
+        <p:txBody>
+          <a:bodyPr/>
+          <a:p/>
+        </p:txBody>
       </p:sp>
       <p:sp>
         <p:nvSpPr>
@@ -4396,6 +4528,10 @@
             <a:prstDash val="solid"/>
           </a:ln>
         </p:spPr>
+        <p:txBody>
+          <a:bodyPr/>
+          <a:p/>
+        </p:txBody>
       </p:sp>
       <p:sp>
         <p:nvSpPr>
@@ -4460,6 +4596,10 @@
             <a:prstDash val="solid"/>
           </a:ln>
         </p:spPr>
+        <p:txBody>
+          <a:bodyPr/>
+          <a:p/>
+        </p:txBody>
       </p:sp>
       <p:pic>
         <p:nvPicPr>
@@ -4548,6 +4688,10 @@
             <a:prstDash val="solid"/>
           </a:ln>
         </p:spPr>
+        <p:txBody>
+          <a:bodyPr/>
+          <a:p/>
+        </p:txBody>
       </p:sp>
       <p:sp>
         <p:nvSpPr>
@@ -4612,6 +4756,10 @@
             <a:prstDash val="solid"/>
           </a:ln>
         </p:spPr>
+        <p:txBody>
+          <a:bodyPr/>
+          <a:p/>
+        </p:txBody>
       </p:sp>
       <p:sp>
         <p:nvSpPr>
@@ -4637,6 +4785,10 @@
             <a:prstDash val="solid"/>
           </a:ln>
         </p:spPr>
+        <p:txBody>
+          <a:bodyPr/>
+          <a:p/>
+        </p:txBody>
       </p:sp>
       <p:sp>
         <p:nvSpPr>
@@ -4740,6 +4892,10 @@
             <a:prstDash val="solid"/>
           </a:ln>
         </p:spPr>
+        <p:txBody>
+          <a:bodyPr/>
+          <a:p/>
+        </p:txBody>
       </p:sp>
       <p:sp>
         <p:nvSpPr>
@@ -4843,6 +4999,10 @@
             <a:prstDash val="solid"/>
           </a:ln>
         </p:spPr>
+        <p:txBody>
+          <a:bodyPr/>
+          <a:p/>
+        </p:txBody>
       </p:sp>
       <p:sp>
         <p:nvSpPr>
@@ -4907,6 +5067,10 @@
             <a:prstDash val="solid"/>
           </a:ln>
         </p:spPr>
+        <p:txBody>
+          <a:bodyPr/>
+          <a:p/>
+        </p:txBody>
       </p:sp>
       <p:pic>
         <p:nvPicPr>
@@ -5006,6 +5170,10 @@
             <a:prstDash val="solid"/>
           </a:ln>
         </p:spPr>
+        <p:txBody>
+          <a:bodyPr/>
+          <a:p/>
+        </p:txBody>
       </p:sp>
       <p:sp>
         <p:nvSpPr>
@@ -5139,6 +5307,10 @@
             <a:prstDash val="solid"/>
           </a:ln>
         </p:spPr>
+        <p:txBody>
+          <a:bodyPr/>
+          <a:p/>
+        </p:txBody>
       </p:sp>
       <p:sp>
         <p:nvSpPr>
@@ -5278,6 +5450,10 @@
             <a:prstDash val="solid"/>
           </a:ln>
         </p:spPr>
+        <p:txBody>
+          <a:bodyPr/>
+          <a:p/>
+        </p:txBody>
       </p:sp>
       <p:sp>
         <p:nvSpPr>
@@ -5303,6 +5479,10 @@
             <a:prstDash val="solid"/>
           </a:ln>
         </p:spPr>
+        <p:txBody>
+          <a:bodyPr/>
+          <a:p/>
+        </p:txBody>
       </p:sp>
       <p:sp>
         <p:nvSpPr>
@@ -5328,6 +5508,10 @@
             <a:prstDash val="solid"/>
           </a:ln>
         </p:spPr>
+        <p:txBody>
+          <a:bodyPr/>
+          <a:p/>
+        </p:txBody>
       </p:sp>
       <p:sp>
         <p:nvSpPr>
@@ -5392,6 +5576,10 @@
             <a:prstDash val="solid"/>
           </a:ln>
         </p:spPr>
+        <p:txBody>
+          <a:bodyPr/>
+          <a:p/>
+        </p:txBody>
       </p:sp>
       <p:sp>
         <p:nvSpPr>
@@ -5495,6 +5683,10 @@
             <a:prstDash val="solid"/>
           </a:ln>
         </p:spPr>
+        <p:txBody>
+          <a:bodyPr/>
+          <a:p/>
+        </p:txBody>
       </p:sp>
       <p:sp>
         <p:nvSpPr>
@@ -5559,6 +5751,10 @@
             <a:prstDash val="solid"/>
           </a:ln>
         </p:spPr>
+        <p:txBody>
+          <a:bodyPr/>
+          <a:p/>
+        </p:txBody>
       </p:sp>
       <p:sp>
         <p:nvSpPr>
@@ -5662,6 +5858,10 @@
             <a:prstDash val="solid"/>
           </a:ln>
         </p:spPr>
+        <p:txBody>
+          <a:bodyPr/>
+          <a:p/>
+        </p:txBody>
       </p:sp>
       <p:sp>
         <p:nvSpPr>
@@ -5726,6 +5926,10 @@
             <a:prstDash val="solid"/>
           </a:ln>
         </p:spPr>
+        <p:txBody>
+          <a:bodyPr/>
+          <a:p/>
+        </p:txBody>
       </p:sp>
       <p:sp>
         <p:nvSpPr>
@@ -5829,6 +6033,10 @@
             <a:prstDash val="solid"/>
           </a:ln>
         </p:spPr>
+        <p:txBody>
+          <a:bodyPr/>
+          <a:p/>
+        </p:txBody>
       </p:sp>
       <p:sp>
         <p:nvSpPr>
@@ -5893,6 +6101,10 @@
             <a:prstDash val="solid"/>
           </a:ln>
         </p:spPr>
+        <p:txBody>
+          <a:bodyPr/>
+          <a:p/>
+        </p:txBody>
       </p:sp>
       <p:sp>
         <p:nvSpPr>
@@ -5996,6 +6208,10 @@
             <a:prstDash val="solid"/>
           </a:ln>
         </p:spPr>
+        <p:txBody>
+          <a:bodyPr/>
+          <a:p/>
+        </p:txBody>
       </p:sp>
       <p:sp>
         <p:nvSpPr>
@@ -6060,6 +6276,10 @@
             <a:prstDash val="solid"/>
           </a:ln>
         </p:spPr>
+        <p:txBody>
+          <a:bodyPr/>
+          <a:p/>
+        </p:txBody>
       </p:sp>
       <p:sp>
         <p:nvSpPr>
@@ -6163,6 +6383,10 @@
             <a:prstDash val="solid"/>
           </a:ln>
         </p:spPr>
+        <p:txBody>
+          <a:bodyPr/>
+          <a:p/>
+        </p:txBody>
       </p:sp>
       <p:sp>
         <p:nvSpPr>
@@ -6227,6 +6451,10 @@
             <a:prstDash val="solid"/>
           </a:ln>
         </p:spPr>
+        <p:txBody>
+          <a:bodyPr/>
+          <a:p/>
+        </p:txBody>
       </p:sp>
       <p:sp>
         <p:nvSpPr>
@@ -6330,6 +6558,10 @@
             <a:prstDash val="solid"/>
           </a:ln>
         </p:spPr>
+        <p:txBody>
+          <a:bodyPr/>
+          <a:p/>
+        </p:txBody>
       </p:sp>
       <p:sp>
         <p:nvSpPr>
@@ -6394,6 +6626,10 @@
             <a:prstDash val="solid"/>
           </a:ln>
         </p:spPr>
+        <p:txBody>
+          <a:bodyPr/>
+          <a:p/>
+        </p:txBody>
       </p:sp>
       <p:sp>
         <p:nvSpPr>
@@ -6497,6 +6733,10 @@
             <a:prstDash val="solid"/>
           </a:ln>
         </p:spPr>
+        <p:txBody>
+          <a:bodyPr/>
+          <a:p/>
+        </p:txBody>
       </p:sp>
       <p:sp>
         <p:nvSpPr>
@@ -6561,6 +6801,10 @@
             <a:prstDash val="solid"/>
           </a:ln>
         </p:spPr>
+        <p:txBody>
+          <a:bodyPr/>
+          <a:p/>
+        </p:txBody>
       </p:sp>
       <p:sp>
         <p:nvSpPr>
@@ -6625,6 +6869,10 @@
             <a:prstDash val="solid"/>
           </a:ln>
         </p:spPr>
+        <p:txBody>
+          <a:bodyPr/>
+          <a:p/>
+        </p:txBody>
       </p:sp>
       <p:sp>
         <p:nvSpPr>
@@ -6650,6 +6898,10 @@
             <a:prstDash val="solid"/>
           </a:ln>
         </p:spPr>
+        <p:txBody>
+          <a:bodyPr/>
+          <a:p/>
+        </p:txBody>
       </p:sp>
       <p:sp>
         <p:nvSpPr>
@@ -6714,6 +6966,10 @@
             <a:prstDash val="solid"/>
           </a:ln>
         </p:spPr>
+        <p:txBody>
+          <a:bodyPr/>
+          <a:p/>
+        </p:txBody>
       </p:sp>
       <p:sp>
         <p:nvSpPr>
@@ -6817,6 +7073,10 @@
             <a:prstDash val="solid"/>
           </a:ln>
         </p:spPr>
+        <p:txBody>
+          <a:bodyPr/>
+          <a:p/>
+        </p:txBody>
       </p:sp>
       <p:sp>
         <p:nvSpPr>
@@ -6920,6 +7180,10 @@
             <a:prstDash val="solid"/>
           </a:ln>
         </p:spPr>
+        <p:txBody>
+          <a:bodyPr/>
+          <a:p/>
+        </p:txBody>
       </p:sp>
       <p:sp>
         <p:nvSpPr>
@@ -6984,6 +7248,10 @@
             <a:prstDash val="solid"/>
           </a:ln>
         </p:spPr>
+        <p:txBody>
+          <a:bodyPr/>
+          <a:p/>
+        </p:txBody>
       </p:sp>
       <p:sp>
         <p:nvSpPr>
@@ -7087,6 +7355,10 @@
             <a:prstDash val="solid"/>
           </a:ln>
         </p:spPr>
+        <p:txBody>
+          <a:bodyPr/>
+          <a:p/>
+        </p:txBody>
       </p:sp>
       <p:sp>
         <p:nvSpPr>
@@ -7190,6 +7462,10 @@
             <a:prstDash val="solid"/>
           </a:ln>
         </p:spPr>
+        <p:txBody>
+          <a:bodyPr/>
+          <a:p/>
+        </p:txBody>
       </p:sp>
       <p:sp>
         <p:nvSpPr>
@@ -7293,6 +7569,10 @@
             <a:prstDash val="solid"/>
           </a:ln>
         </p:spPr>
+        <p:txBody>
+          <a:bodyPr/>
+          <a:p/>
+        </p:txBody>
       </p:sp>
       <p:sp>
         <p:nvSpPr>
@@ -7396,6 +7676,10 @@
             <a:prstDash val="solid"/>
           </a:ln>
         </p:spPr>
+        <p:txBody>
+          <a:bodyPr/>
+          <a:p/>
+        </p:txBody>
       </p:sp>
       <p:sp>
         <p:nvSpPr>
@@ -7529,6 +7813,10 @@
             <a:prstDash val="solid"/>
           </a:ln>
         </p:spPr>
+        <p:txBody>
+          <a:bodyPr/>
+          <a:p/>
+        </p:txBody>
       </p:sp>
       <p:sp>
         <p:nvSpPr>
@@ -7668,6 +7956,10 @@
             <a:prstDash val="solid"/>
           </a:ln>
         </p:spPr>
+        <p:txBody>
+          <a:bodyPr/>
+          <a:p/>
+        </p:txBody>
       </p:sp>
       <p:sp>
         <p:nvSpPr>
@@ -7693,6 +7985,10 @@
             <a:prstDash val="solid"/>
           </a:ln>
         </p:spPr>
+        <p:txBody>
+          <a:bodyPr/>
+          <a:p/>
+        </p:txBody>
       </p:sp>
       <p:sp>
         <p:nvSpPr>
@@ -7718,6 +8014,10 @@
             <a:prstDash val="solid"/>
           </a:ln>
         </p:spPr>
+        <p:txBody>
+          <a:bodyPr/>
+          <a:p/>
+        </p:txBody>
       </p:sp>
       <p:pic>
         <p:nvPicPr>
@@ -7806,6 +8106,10 @@
             <a:prstDash val="solid"/>
           </a:ln>
         </p:spPr>
+        <p:txBody>
+          <a:bodyPr/>
+          <a:p/>
+        </p:txBody>
       </p:sp>
       <p:sp>
         <p:nvSpPr>
@@ -7831,6 +8135,10 @@
             <a:prstDash val="solid"/>
           </a:ln>
         </p:spPr>
+        <p:txBody>
+          <a:bodyPr/>
+          <a:p/>
+        </p:txBody>
       </p:sp>
       <p:sp>
         <p:nvSpPr>
@@ -7906,6 +8214,10 @@
             <a:prstDash val="solid"/>
           </a:ln>
         </p:spPr>
+        <p:txBody>
+          <a:bodyPr/>
+          <a:p/>
+        </p:txBody>
       </p:sp>
       <p:sp>
         <p:nvSpPr>
@@ -7931,6 +8243,10 @@
             <a:prstDash val="solid"/>
           </a:ln>
         </p:spPr>
+        <p:txBody>
+          <a:bodyPr/>
+          <a:p/>
+        </p:txBody>
       </p:sp>
       <p:sp>
         <p:nvSpPr>
@@ -8006,6 +8322,10 @@
             <a:prstDash val="solid"/>
           </a:ln>
         </p:spPr>
+        <p:txBody>
+          <a:bodyPr/>
+          <a:p/>
+        </p:txBody>
       </p:sp>
       <p:sp>
         <p:nvSpPr>
@@ -8031,6 +8351,10 @@
             <a:prstDash val="solid"/>
           </a:ln>
         </p:spPr>
+        <p:txBody>
+          <a:bodyPr/>
+          <a:p/>
+        </p:txBody>
       </p:sp>
       <p:sp>
         <p:nvSpPr>
@@ -8106,6 +8430,10 @@
             <a:prstDash val="solid"/>
           </a:ln>
         </p:spPr>
+        <p:txBody>
+          <a:bodyPr/>
+          <a:p/>
+        </p:txBody>
       </p:sp>
       <p:sp>
         <p:nvSpPr>
@@ -8131,6 +8459,10 @@
             <a:prstDash val="solid"/>
           </a:ln>
         </p:spPr>
+        <p:txBody>
+          <a:bodyPr/>
+          <a:p/>
+        </p:txBody>
       </p:sp>
       <p:sp>
         <p:nvSpPr>
@@ -8206,6 +8538,10 @@
             <a:prstDash val="solid"/>
           </a:ln>
         </p:spPr>
+        <p:txBody>
+          <a:bodyPr/>
+          <a:p/>
+        </p:txBody>
       </p:sp>
       <p:sp>
         <p:nvSpPr>
@@ -8231,6 +8567,10 @@
             <a:prstDash val="solid"/>
           </a:ln>
         </p:spPr>
+        <p:txBody>
+          <a:bodyPr/>
+          <a:p/>
+        </p:txBody>
       </p:sp>
       <p:sp>
         <p:nvSpPr>
@@ -8306,6 +8646,10 @@
             <a:prstDash val="solid"/>
           </a:ln>
         </p:spPr>
+        <p:txBody>
+          <a:bodyPr/>
+          <a:p/>
+        </p:txBody>
       </p:sp>
       <p:sp>
         <p:nvSpPr>
@@ -8331,6 +8675,10 @@
             <a:prstDash val="solid"/>
           </a:ln>
         </p:spPr>
+        <p:txBody>
+          <a:bodyPr/>
+          <a:p/>
+        </p:txBody>
       </p:sp>
       <p:pic>
         <p:nvPicPr>
@@ -8419,6 +8767,10 @@
             <a:prstDash val="solid"/>
           </a:ln>
         </p:spPr>
+        <p:txBody>
+          <a:bodyPr/>
+          <a:p/>
+        </p:txBody>
       </p:sp>
       <p:sp>
         <p:nvSpPr>
@@ -8444,6 +8796,10 @@
             <a:prstDash val="solid"/>
           </a:ln>
         </p:spPr>
+        <p:txBody>
+          <a:bodyPr/>
+          <a:p/>
+        </p:txBody>
       </p:sp>
       <p:sp>
         <p:nvSpPr>
@@ -8528,7 +8884,7 @@
                 <a:ea typeface="Calibri" pitchFamily="34" charset="-122"/>
                 <a:cs typeface="Calibri" pitchFamily="34" charset="-120"/>
               </a:rPr>
-              <a:t>Fabricate PCB, procure IRFZ44N (upgrade to IRFB4110: RDS(on) 3.7 mΩ, −86% conduction loss).</a:t>
+              <a:t>Fabricate PCB, procure IRFB4110 (RDS(on) 3.7 mΩ).</a:t>
             </a:r>
             <a:endParaRPr lang="en-US" sz="950" dirty="0"/>
           </a:p>
@@ -8558,6 +8914,10 @@
             <a:prstDash val="solid"/>
           </a:ln>
         </p:spPr>
+        <p:txBody>
+          <a:bodyPr/>
+          <a:p/>
+        </p:txBody>
       </p:sp>
       <p:sp>
         <p:nvSpPr>
@@ -8583,6 +8943,10 @@
             <a:prstDash val="solid"/>
           </a:ln>
         </p:spPr>
+        <p:txBody>
+          <a:bodyPr/>
+          <a:p/>
+        </p:txBody>
       </p:sp>
       <p:sp>
         <p:nvSpPr>
@@ -8697,6 +9061,10 @@
             <a:prstDash val="solid"/>
           </a:ln>
         </p:spPr>
+        <p:txBody>
+          <a:bodyPr/>
+          <a:p/>
+        </p:txBody>
       </p:sp>
       <p:sp>
         <p:nvSpPr>
@@ -8722,6 +9090,10 @@
             <a:prstDash val="solid"/>
           </a:ln>
         </p:spPr>
+        <p:txBody>
+          <a:bodyPr/>
+          <a:p/>
+        </p:txBody>
       </p:sp>
       <p:sp>
         <p:nvSpPr>
@@ -8836,6 +9208,10 @@
             <a:prstDash val="solid"/>
           </a:ln>
         </p:spPr>
+        <p:txBody>
+          <a:bodyPr/>
+          <a:p/>
+        </p:txBody>
       </p:sp>
       <p:sp>
         <p:nvSpPr>
@@ -8861,6 +9237,10 @@
             <a:prstDash val="solid"/>
           </a:ln>
         </p:spPr>
+        <p:txBody>
+          <a:bodyPr/>
+          <a:p/>
+        </p:txBody>
       </p:sp>
       <p:sp>
         <p:nvSpPr>
@@ -8975,6 +9355,10 @@
             <a:prstDash val="solid"/>
           </a:ln>
         </p:spPr>
+        <p:txBody>
+          <a:bodyPr/>
+          <a:p/>
+        </p:txBody>
       </p:sp>
       <p:sp>
         <p:nvSpPr>
@@ -9000,6 +9384,10 @@
             <a:prstDash val="solid"/>
           </a:ln>
         </p:spPr>
+        <p:txBody>
+          <a:bodyPr/>
+          <a:p/>
+        </p:txBody>
       </p:sp>
       <p:sp>
         <p:nvSpPr>
@@ -9114,6 +9502,10 @@
             <a:prstDash val="solid"/>
           </a:ln>
         </p:spPr>
+        <p:txBody>
+          <a:bodyPr/>
+          <a:p/>
+        </p:txBody>
       </p:sp>
       <p:sp>
         <p:nvSpPr>
@@ -9247,6 +9639,10 @@
             <a:prstDash val="solid"/>
           </a:ln>
         </p:spPr>
+        <p:txBody>
+          <a:bodyPr/>
+          <a:p/>
+        </p:txBody>
       </p:sp>
       <p:sp>
         <p:nvSpPr>
@@ -9272,6 +9668,10 @@
             <a:prstDash val="solid"/>
           </a:ln>
         </p:spPr>
+        <p:txBody>
+          <a:bodyPr/>
+          <a:p/>
+        </p:txBody>
       </p:sp>
       <p:sp>
         <p:nvSpPr>
@@ -9336,6 +9736,10 @@
             <a:prstDash val="solid"/>
           </a:ln>
         </p:spPr>
+        <p:txBody>
+          <a:bodyPr/>
+          <a:p/>
+        </p:txBody>
       </p:sp>
       <p:sp>
         <p:nvSpPr>
@@ -9361,6 +9765,10 @@
             <a:prstDash val="solid"/>
           </a:ln>
         </p:spPr>
+        <p:txBody>
+          <a:bodyPr/>
+          <a:p/>
+        </p:txBody>
       </p:sp>
       <p:pic>
         <p:nvPicPr>
@@ -9488,6 +9896,10 @@
             <a:prstDash val="solid"/>
           </a:ln>
         </p:spPr>
+        <p:txBody>
+          <a:bodyPr/>
+          <a:p/>
+        </p:txBody>
       </p:sp>
       <p:pic>
         <p:nvPicPr>
@@ -9615,6 +10027,10 @@
             <a:prstDash val="solid"/>
           </a:ln>
         </p:spPr>
+        <p:txBody>
+          <a:bodyPr/>
+          <a:p/>
+        </p:txBody>
       </p:sp>
       <p:pic>
         <p:nvPicPr>
@@ -9742,6 +10158,10 @@
             <a:prstDash val="solid"/>
           </a:ln>
         </p:spPr>
+        <p:txBody>
+          <a:bodyPr/>
+          <a:p/>
+        </p:txBody>
       </p:sp>
       <p:pic>
         <p:nvPicPr>
@@ -9869,6 +10289,10 @@
             <a:prstDash val="solid"/>
           </a:ln>
         </p:spPr>
+        <p:txBody>
+          <a:bodyPr/>
+          <a:p/>
+        </p:txBody>
       </p:sp>
       <p:pic>
         <p:nvPicPr>
@@ -9996,6 +10420,10 @@
             <a:prstDash val="solid"/>
           </a:ln>
         </p:spPr>
+        <p:txBody>
+          <a:bodyPr/>
+          <a:p/>
+        </p:txBody>
       </p:sp>
       <p:pic>
         <p:nvPicPr>
@@ -10231,6 +10659,10 @@
             <a:prstDash val="solid"/>
           </a:ln>
         </p:spPr>
+        <p:txBody>
+          <a:bodyPr/>
+          <a:p/>
+        </p:txBody>
       </p:sp>
       <p:sp>
         <p:nvSpPr>
@@ -10370,6 +10802,10 @@
             <a:prstDash val="solid"/>
           </a:ln>
         </p:spPr>
+        <p:txBody>
+          <a:bodyPr/>
+          <a:p/>
+        </p:txBody>
       </p:sp>
       <p:sp>
         <p:nvSpPr>
@@ -10478,6 +10914,10 @@
             <a:prstDash val="solid"/>
           </a:ln>
         </p:spPr>
+        <p:txBody>
+          <a:bodyPr/>
+          <a:p/>
+        </p:txBody>
       </p:sp>
       <p:sp>
         <p:nvSpPr>
@@ -10503,6 +10943,10 @@
             <a:prstDash val="solid"/>
           </a:ln>
         </p:spPr>
+        <p:txBody>
+          <a:bodyPr/>
+          <a:p/>
+        </p:txBody>
       </p:sp>
       <p:sp>
         <p:nvSpPr>
@@ -10645,6 +11089,10 @@
             <a:prstDash val="solid"/>
           </a:ln>
         </p:spPr>
+        <p:txBody>
+          <a:bodyPr/>
+          <a:p/>
+        </p:txBody>
       </p:sp>
       <p:sp>
         <p:nvSpPr>
@@ -10670,6 +11118,10 @@
             <a:prstDash val="solid"/>
           </a:ln>
         </p:spPr>
+        <p:txBody>
+          <a:bodyPr/>
+          <a:p/>
+        </p:txBody>
       </p:sp>
       <p:sp>
         <p:nvSpPr>
@@ -10812,6 +11264,10 @@
             <a:prstDash val="solid"/>
           </a:ln>
         </p:spPr>
+        <p:txBody>
+          <a:bodyPr/>
+          <a:p/>
+        </p:txBody>
       </p:sp>
       <p:sp>
         <p:nvSpPr>
@@ -10837,6 +11293,10 @@
             <a:prstDash val="solid"/>
           </a:ln>
         </p:spPr>
+        <p:txBody>
+          <a:bodyPr/>
+          <a:p/>
+        </p:txBody>
       </p:sp>
       <p:sp>
         <p:nvSpPr>
@@ -10979,6 +11439,10 @@
             <a:prstDash val="solid"/>
           </a:ln>
         </p:spPr>
+        <p:txBody>
+          <a:bodyPr/>
+          <a:p/>
+        </p:txBody>
       </p:sp>
       <p:sp>
         <p:nvSpPr>
@@ -11004,6 +11468,10 @@
             <a:prstDash val="solid"/>
           </a:ln>
         </p:spPr>
+        <p:txBody>
+          <a:bodyPr/>
+          <a:p/>
+        </p:txBody>
       </p:sp>
       <p:sp>
         <p:nvSpPr>
@@ -11068,6 +11536,10 @@
             <a:prstDash val="solid"/>
           </a:ln>
         </p:spPr>
+        <p:txBody>
+          <a:bodyPr/>
+          <a:p/>
+        </p:txBody>
       </p:sp>
       <p:sp>
         <p:nvSpPr>
@@ -11143,6 +11615,10 @@
             <a:prstDash val="solid"/>
           </a:ln>
         </p:spPr>
+        <p:txBody>
+          <a:bodyPr/>
+          <a:p/>
+        </p:txBody>
       </p:sp>
       <p:sp>
         <p:nvSpPr>
@@ -11218,6 +11694,10 @@
             <a:prstDash val="solid"/>
           </a:ln>
         </p:spPr>
+        <p:txBody>
+          <a:bodyPr/>
+          <a:p/>
+        </p:txBody>
       </p:sp>
       <p:sp>
         <p:nvSpPr>
@@ -11293,6 +11773,10 @@
             <a:prstDash val="solid"/>
           </a:ln>
         </p:spPr>
+        <p:txBody>
+          <a:bodyPr/>
+          <a:p/>
+        </p:txBody>
       </p:sp>
       <p:sp>
         <p:nvSpPr>
@@ -11437,6 +11921,10 @@
             <a:prstDash val="solid"/>
           </a:ln>
         </p:spPr>
+        <p:txBody>
+          <a:bodyPr/>
+          <a:p/>
+        </p:txBody>
       </p:sp>
       <p:sp>
         <p:nvSpPr>
@@ -11576,6 +12064,10 @@
             <a:prstDash val="solid"/>
           </a:ln>
         </p:spPr>
+        <p:txBody>
+          <a:bodyPr/>
+          <a:p/>
+        </p:txBody>
       </p:sp>
       <p:sp>
         <p:nvSpPr>
@@ -11601,6 +12093,10 @@
             <a:prstDash val="solid"/>
           </a:ln>
         </p:spPr>
+        <p:txBody>
+          <a:bodyPr/>
+          <a:p/>
+        </p:txBody>
       </p:sp>
       <p:sp>
         <p:nvSpPr>
@@ -11626,6 +12122,10 @@
             <a:prstDash val="solid"/>
           </a:ln>
         </p:spPr>
+        <p:txBody>
+          <a:bodyPr/>
+          <a:p/>
+        </p:txBody>
       </p:sp>
       <p:pic>
         <p:nvPicPr>
@@ -11714,6 +12214,10 @@
             <a:prstDash val="solid"/>
           </a:ln>
         </p:spPr>
+        <p:txBody>
+          <a:bodyPr/>
+          <a:p/>
+        </p:txBody>
       </p:sp>
       <p:sp>
         <p:nvSpPr>
@@ -11817,6 +12321,10 @@
             <a:prstDash val="solid"/>
           </a:ln>
         </p:spPr>
+        <p:txBody>
+          <a:bodyPr/>
+          <a:p/>
+        </p:txBody>
       </p:sp>
       <p:sp>
         <p:nvSpPr>
@@ -11890,7 +12398,7 @@
                 <a:ea typeface="Calibri" pitchFamily="34" charset="-122"/>
                 <a:cs typeface="Calibri" pitchFamily="34" charset="-120"/>
               </a:rPr>
-              <a:t>32-unit model, 7,430 params</a:t>
+              <a:t>32-unit model, 4,486 params</a:t>
             </a:r>
             <a:endParaRPr lang="en-US" sz="950" dirty="0"/>
           </a:p>
@@ -11920,6 +12428,10 @@
             <a:prstDash val="solid"/>
           </a:ln>
         </p:spPr>
+        <p:txBody>
+          <a:bodyPr/>
+          <a:p/>
+        </p:txBody>
       </p:sp>
       <p:sp>
         <p:nvSpPr>
@@ -12023,6 +12535,10 @@
             <a:prstDash val="solid"/>
           </a:ln>
         </p:spPr>
+        <p:txBody>
+          <a:bodyPr/>
+          <a:p/>
+        </p:txBody>
       </p:sp>
       <p:sp>
         <p:nvSpPr>
@@ -12126,6 +12642,10 @@
             <a:prstDash val="solid"/>
           </a:ln>
         </p:spPr>
+        <p:txBody>
+          <a:bodyPr/>
+          <a:p/>
+        </p:txBody>
       </p:sp>
       <p:sp>
         <p:nvSpPr>
@@ -12229,6 +12749,10 @@
             <a:prstDash val="solid"/>
           </a:ln>
         </p:spPr>
+        <p:txBody>
+          <a:bodyPr/>
+          <a:p/>
+        </p:txBody>
       </p:sp>
       <p:sp>
         <p:nvSpPr>
@@ -12332,6 +12856,10 @@
             <a:prstDash val="solid"/>
           </a:ln>
         </p:spPr>
+        <p:txBody>
+          <a:bodyPr/>
+          <a:p/>
+        </p:txBody>
       </p:sp>
       <p:sp>
         <p:nvSpPr>
@@ -12357,6 +12885,10 @@
             <a:prstDash val="solid"/>
           </a:ln>
         </p:spPr>
+        <p:txBody>
+          <a:bodyPr/>
+          <a:p/>
+        </p:txBody>
       </p:sp>
       <p:sp>
         <p:nvSpPr>
@@ -12460,6 +12992,10 @@
             <a:prstDash val="solid"/>
           </a:ln>
         </p:spPr>
+        <p:txBody>
+          <a:bodyPr/>
+          <a:p/>
+        </p:txBody>
       </p:sp>
       <p:sp>
         <p:nvSpPr>
@@ -12485,6 +13021,10 @@
             <a:prstDash val="solid"/>
           </a:ln>
         </p:spPr>
+        <p:txBody>
+          <a:bodyPr/>
+          <a:p/>
+        </p:txBody>
       </p:sp>
       <p:pic>
         <p:nvPicPr>
@@ -12573,6 +13113,10 @@
             <a:prstDash val="solid"/>
           </a:ln>
         </p:spPr>
+        <p:txBody>
+          <a:bodyPr/>
+          <a:p/>
+        </p:txBody>
       </p:sp>
       <p:sp>
         <p:nvSpPr>
@@ -12676,6 +13220,10 @@
             <a:prstDash val="solid"/>
           </a:ln>
         </p:spPr>
+        <p:txBody>
+          <a:bodyPr/>
+          <a:p/>
+        </p:txBody>
       </p:sp>
       <p:sp>
         <p:nvSpPr>
@@ -12710,7 +13258,7 @@
                 <a:ea typeface="Calibri" pitchFamily="34" charset="-122"/>
                 <a:cs typeface="Calibri" pitchFamily="34" charset="-120"/>
               </a:rPr>
-              <a:t>50 kHz PWM — IRFZ44N via TC4420</a:t>
+              <a:t>50 kHz PWM — IRFB4110 via TC4420</a:t>
             </a:r>
             <a:endParaRPr lang="en-US" sz="1050" dirty="0"/>
           </a:p>
@@ -12779,6 +13327,10 @@
             <a:prstDash val="solid"/>
           </a:ln>
         </p:spPr>
+        <p:txBody>
+          <a:bodyPr/>
+          <a:p/>
+        </p:txBody>
       </p:sp>
       <p:sp>
         <p:nvSpPr>
@@ -12882,6 +13434,10 @@
             <a:prstDash val="solid"/>
           </a:ln>
         </p:spPr>
+        <p:txBody>
+          <a:bodyPr/>
+          <a:p/>
+        </p:txBody>
       </p:sp>
       <p:sp>
         <p:nvSpPr>
@@ -12985,6 +13541,10 @@
             <a:prstDash val="solid"/>
           </a:ln>
         </p:spPr>
+        <p:txBody>
+          <a:bodyPr/>
+          <a:p/>
+        </p:txBody>
       </p:sp>
       <p:sp>
         <p:nvSpPr>
@@ -13088,6 +13648,10 @@
             <a:prstDash val="solid"/>
           </a:ln>
         </p:spPr>
+        <p:txBody>
+          <a:bodyPr/>
+          <a:p/>
+        </p:txBody>
       </p:sp>
       <p:sp>
         <p:nvSpPr>
@@ -13260,6 +13824,10 @@
             <a:prstDash val="solid"/>
           </a:ln>
         </p:spPr>
+        <p:txBody>
+          <a:bodyPr/>
+          <a:p/>
+        </p:txBody>
       </p:sp>
       <p:sp>
         <p:nvSpPr>
@@ -13399,6 +13967,10 @@
             <a:prstDash val="solid"/>
           </a:ln>
         </p:spPr>
+        <p:txBody>
+          <a:bodyPr/>
+          <a:p/>
+        </p:txBody>
       </p:sp>
       <p:sp>
         <p:nvSpPr>
@@ -13424,6 +13996,10 @@
             <a:prstDash val="solid"/>
           </a:ln>
         </p:spPr>
+        <p:txBody>
+          <a:bodyPr/>
+          <a:p/>
+        </p:txBody>
       </p:sp>
       <p:sp>
         <p:nvSpPr>
@@ -13449,6 +14025,10 @@
             <a:prstDash val="solid"/>
           </a:ln>
         </p:spPr>
+        <p:txBody>
+          <a:bodyPr/>
+          <a:p/>
+        </p:txBody>
       </p:sp>
       <p:sp>
         <p:nvSpPr>
@@ -13513,6 +14093,10 @@
             <a:prstDash val="solid"/>
           </a:ln>
         </p:spPr>
+        <p:txBody>
+          <a:bodyPr/>
+          <a:p/>
+        </p:txBody>
       </p:sp>
       <p:sp>
         <p:nvSpPr>
@@ -13616,6 +14200,10 @@
             <a:prstDash val="solid"/>
           </a:ln>
         </p:spPr>
+        <p:txBody>
+          <a:bodyPr/>
+          <a:p/>
+        </p:txBody>
       </p:sp>
       <p:sp>
         <p:nvSpPr>
@@ -13719,6 +14307,10 @@
             <a:prstDash val="solid"/>
           </a:ln>
         </p:spPr>
+        <p:txBody>
+          <a:bodyPr/>
+          <a:p/>
+        </p:txBody>
       </p:sp>
       <p:sp>
         <p:nvSpPr>
@@ -13822,6 +14414,10 @@
             <a:prstDash val="solid"/>
           </a:ln>
         </p:spPr>
+        <p:txBody>
+          <a:bodyPr/>
+          <a:p/>
+        </p:txBody>
       </p:sp>
       <p:sp>
         <p:nvSpPr>
@@ -13925,6 +14521,10 @@
             <a:prstDash val="solid"/>
           </a:ln>
         </p:spPr>
+        <p:txBody>
+          <a:bodyPr/>
+          <a:p/>
+        </p:txBody>
       </p:sp>
       <p:sp>
         <p:nvSpPr>
@@ -14028,6 +14628,10 @@
             <a:prstDash val="solid"/>
           </a:ln>
         </p:spPr>
+        <p:txBody>
+          <a:bodyPr/>
+          <a:p/>
+        </p:txBody>
       </p:sp>
       <p:sp>
         <p:nvSpPr>
@@ -14131,6 +14735,10 @@
             <a:prstDash val="solid"/>
           </a:ln>
         </p:spPr>
+        <p:txBody>
+          <a:bodyPr/>
+          <a:p/>
+        </p:txBody>
       </p:sp>
       <p:sp>
         <p:nvSpPr>
@@ -14234,6 +14842,10 @@
             <a:prstDash val="solid"/>
           </a:ln>
         </p:spPr>
+        <p:txBody>
+          <a:bodyPr/>
+          <a:p/>
+        </p:txBody>
       </p:sp>
       <p:sp>
         <p:nvSpPr>
@@ -14337,6 +14949,10 @@
             <a:prstDash val="solid"/>
           </a:ln>
         </p:spPr>
+        <p:txBody>
+          <a:bodyPr/>
+          <a:p/>
+        </p:txBody>
       </p:sp>
       <p:sp>
         <p:nvSpPr>
@@ -14362,6 +14978,10 @@
             <a:prstDash val="solid"/>
           </a:ln>
         </p:spPr>
+        <p:txBody>
+          <a:bodyPr/>
+          <a:p/>
+        </p:txBody>
       </p:sp>
       <p:sp>
         <p:nvSpPr>
@@ -14426,6 +15046,10 @@
             <a:prstDash val="solid"/>
           </a:ln>
         </p:spPr>
+        <p:txBody>
+          <a:bodyPr/>
+          <a:p/>
+        </p:txBody>
       </p:sp>
       <p:sp>
         <p:nvSpPr>
@@ -14499,7 +15123,7 @@
                 <a:ea typeface="Calibri" pitchFamily="34" charset="-122"/>
                 <a:cs typeface="Calibri" pitchFamily="34" charset="-120"/>
               </a:rPr>
-              <a:t>IRFZ44N — VDS 60V, RDS(on) 28 mΩ</a:t>
+              <a:t>IRFB4110 — VDS 60V, RDS(on) 28 mΩ</a:t>
             </a:r>
             <a:endParaRPr lang="en-US" sz="950" dirty="0"/>
           </a:p>
@@ -14529,6 +15153,10 @@
             <a:prstDash val="solid"/>
           </a:ln>
         </p:spPr>
+        <p:txBody>
+          <a:bodyPr/>
+          <a:p/>
+        </p:txBody>
       </p:sp>
       <p:sp>
         <p:nvSpPr>
@@ -14632,6 +15260,10 @@
             <a:prstDash val="solid"/>
           </a:ln>
         </p:spPr>
+        <p:txBody>
+          <a:bodyPr/>
+          <a:p/>
+        </p:txBody>
       </p:sp>
       <p:sp>
         <p:nvSpPr>
@@ -14735,6 +15367,10 @@
             <a:prstDash val="solid"/>
           </a:ln>
         </p:spPr>
+        <p:txBody>
+          <a:bodyPr/>
+          <a:p/>
+        </p:txBody>
       </p:sp>
       <p:sp>
         <p:nvSpPr>
@@ -14838,6 +15474,10 @@
             <a:prstDash val="solid"/>
           </a:ln>
         </p:spPr>
+        <p:txBody>
+          <a:bodyPr/>
+          <a:p/>
+        </p:txBody>
       </p:sp>
       <p:sp>
         <p:nvSpPr>
@@ -14941,6 +15581,10 @@
             <a:prstDash val="solid"/>
           </a:ln>
         </p:spPr>
+        <p:txBody>
+          <a:bodyPr/>
+          <a:p/>
+        </p:txBody>
       </p:sp>
       <p:sp>
         <p:nvSpPr>
@@ -15083,6 +15727,10 @@
             <a:prstDash val="solid"/>
           </a:ln>
         </p:spPr>
+        <p:txBody>
+          <a:bodyPr/>
+          <a:p/>
+        </p:txBody>
       </p:sp>
       <p:sp>
         <p:nvSpPr>
@@ -15186,6 +15834,10 @@
             <a:prstDash val="solid"/>
           </a:ln>
         </p:spPr>
+        <p:txBody>
+          <a:bodyPr/>
+          <a:p/>
+        </p:txBody>
       </p:sp>
       <p:sp>
         <p:nvSpPr>
@@ -15289,6 +15941,10 @@
             <a:prstDash val="solid"/>
           </a:ln>
         </p:spPr>
+        <p:txBody>
+          <a:bodyPr/>
+          <a:p/>
+        </p:txBody>
       </p:sp>
       <p:sp>
         <p:nvSpPr>
@@ -15461,6 +16117,10 @@
             <a:prstDash val="solid"/>
           </a:ln>
         </p:spPr>
+        <p:txBody>
+          <a:bodyPr/>
+          <a:p/>
+        </p:txBody>
       </p:sp>
       <p:sp>
         <p:nvSpPr>
@@ -15600,6 +16260,10 @@
             <a:prstDash val="solid"/>
           </a:ln>
         </p:spPr>
+        <p:txBody>
+          <a:bodyPr/>
+          <a:p/>
+        </p:txBody>
       </p:sp>
       <p:sp>
         <p:nvSpPr>
@@ -15625,6 +16289,10 @@
             <a:prstDash val="solid"/>
           </a:ln>
         </p:spPr>
+        <p:txBody>
+          <a:bodyPr/>
+          <a:p/>
+        </p:txBody>
       </p:sp>
       <p:sp>
         <p:nvSpPr>
@@ -15650,6 +16318,10 @@
             <a:prstDash val="solid"/>
           </a:ln>
         </p:spPr>
+        <p:txBody>
+          <a:bodyPr/>
+          <a:p/>
+        </p:txBody>
       </p:sp>
       <p:sp>
         <p:nvSpPr>
@@ -15714,6 +16386,10 @@
             <a:prstDash val="solid"/>
           </a:ln>
         </p:spPr>
+        <p:txBody>
+          <a:bodyPr/>
+          <a:p/>
+        </p:txBody>
       </p:sp>
       <p:sp>
         <p:nvSpPr>
@@ -16060,7 +16736,7 @@
                 <a:ea typeface="Calibri" pitchFamily="34" charset="-122"/>
                 <a:cs typeface="Calibri" pitchFamily="34" charset="-120"/>
               </a:rPr>
-              <a:t>7,329</a:t>
+              <a:t>4,385</a:t>
             </a:r>
             <a:endParaRPr lang="en-US" sz="900" dirty="0"/>
           </a:p>
@@ -16168,6 +16844,10 @@
             <a:prstDash val="solid"/>
           </a:ln>
         </p:spPr>
+        <p:txBody>
+          <a:bodyPr/>
+          <a:p/>
+        </p:txBody>
       </p:sp>
       <p:sp>
         <p:nvSpPr>
@@ -16436,7 +17116,7 @@
                 <a:ea typeface="Calibri" pitchFamily="34" charset="-122"/>
                 <a:cs typeface="Calibri" pitchFamily="34" charset="-120"/>
               </a:rPr>
-              <a:t>101  (total dual-model: 7,430)</a:t>
+              <a:t>101  (total dual-model: 4,486)</a:t>
             </a:r>
             <a:endParaRPr lang="en-US" sz="900" dirty="0"/>
           </a:p>
@@ -16466,6 +17146,10 @@
             <a:prstDash val="solid"/>
           </a:ln>
         </p:spPr>
+        <p:txBody>
+          <a:bodyPr/>
+          <a:p/>
+        </p:txBody>
       </p:sp>
       <p:sp>
         <p:nvSpPr>
@@ -16491,6 +17175,10 @@
             <a:prstDash val="solid"/>
           </a:ln>
         </p:spPr>
+        <p:txBody>
+          <a:bodyPr/>
+          <a:p/>
+        </p:txBody>
       </p:sp>
       <p:sp>
         <p:nvSpPr>
@@ -16555,6 +17243,10 @@
             <a:prstDash val="solid"/>
           </a:ln>
         </p:spPr>
+        <p:txBody>
+          <a:bodyPr/>
+          <a:p/>
+        </p:txBody>
       </p:sp>
       <p:sp>
         <p:nvSpPr>
@@ -16580,6 +17272,10 @@
             <a:prstDash val="solid"/>
           </a:ln>
         </p:spPr>
+        <p:txBody>
+          <a:bodyPr/>
+          <a:p/>
+        </p:txBody>
       </p:sp>
       <p:sp>
         <p:nvSpPr>
@@ -16683,6 +17379,10 @@
             <a:prstDash val="solid"/>
           </a:ln>
         </p:spPr>
+        <p:txBody>
+          <a:bodyPr/>
+          <a:p/>
+        </p:txBody>
       </p:sp>
       <p:sp>
         <p:nvSpPr>
@@ -16708,6 +17408,10 @@
             <a:prstDash val="solid"/>
           </a:ln>
         </p:spPr>
+        <p:txBody>
+          <a:bodyPr/>
+          <a:p/>
+        </p:txBody>
       </p:sp>
       <p:sp>
         <p:nvSpPr>
@@ -16811,6 +17515,10 @@
             <a:prstDash val="solid"/>
           </a:ln>
         </p:spPr>
+        <p:txBody>
+          <a:bodyPr/>
+          <a:p/>
+        </p:txBody>
       </p:sp>
       <p:sp>
         <p:nvSpPr>
@@ -16836,6 +17544,10 @@
             <a:prstDash val="solid"/>
           </a:ln>
         </p:spPr>
+        <p:txBody>
+          <a:bodyPr/>
+          <a:p/>
+        </p:txBody>
       </p:sp>
       <p:sp>
         <p:nvSpPr>
@@ -16939,6 +17651,10 @@
             <a:prstDash val="solid"/>
           </a:ln>
         </p:spPr>
+        <p:txBody>
+          <a:bodyPr/>
+          <a:p/>
+        </p:txBody>
       </p:sp>
       <p:sp>
         <p:nvSpPr>
@@ -17014,6 +17730,10 @@
             <a:prstDash val="solid"/>
           </a:ln>
         </p:spPr>
+        <p:txBody>
+          <a:bodyPr/>
+          <a:p/>
+        </p:txBody>
       </p:sp>
       <p:sp>
         <p:nvSpPr>
@@ -17186,6 +17906,10 @@
             <a:prstDash val="solid"/>
           </a:ln>
         </p:spPr>
+        <p:txBody>
+          <a:bodyPr/>
+          <a:p/>
+        </p:txBody>
       </p:sp>
       <p:sp>
         <p:nvSpPr>
@@ -17325,6 +18049,10 @@
             <a:prstDash val="solid"/>
           </a:ln>
         </p:spPr>
+        <p:txBody>
+          <a:bodyPr/>
+          <a:p/>
+        </p:txBody>
       </p:sp>
       <p:sp>
         <p:nvSpPr>
@@ -17357,6 +18085,10 @@
             </a:outerShdw>
           </a:effectLst>
         </p:spPr>
+        <p:txBody>
+          <a:bodyPr/>
+          <a:p/>
+        </p:txBody>
       </p:sp>
       <p:sp>
         <p:nvSpPr>
@@ -17382,6 +18114,10 @@
             <a:prstDash val="solid"/>
           </a:ln>
         </p:spPr>
+        <p:txBody>
+          <a:bodyPr/>
+          <a:p/>
+        </p:txBody>
       </p:sp>
       <p:pic>
         <p:nvPicPr>
@@ -17571,6 +18307,10 @@
             </a:outerShdw>
           </a:effectLst>
         </p:spPr>
+        <p:txBody>
+          <a:bodyPr/>
+          <a:p/>
+        </p:txBody>
       </p:sp>
       <p:sp>
         <p:nvSpPr>
@@ -17596,6 +18336,10 @@
             <a:prstDash val="solid"/>
           </a:ln>
         </p:spPr>
+        <p:txBody>
+          <a:bodyPr/>
+          <a:p/>
+        </p:txBody>
       </p:sp>
       <p:pic>
         <p:nvPicPr>
@@ -17785,6 +18529,10 @@
             </a:outerShdw>
           </a:effectLst>
         </p:spPr>
+        <p:txBody>
+          <a:bodyPr/>
+          <a:p/>
+        </p:txBody>
       </p:sp>
       <p:sp>
         <p:nvSpPr>
@@ -17810,6 +18558,10 @@
             <a:prstDash val="solid"/>
           </a:ln>
         </p:spPr>
+        <p:txBody>
+          <a:bodyPr/>
+          <a:p/>
+        </p:txBody>
       </p:sp>
       <p:pic>
         <p:nvPicPr>
@@ -17999,6 +18751,10 @@
             </a:outerShdw>
           </a:effectLst>
         </p:spPr>
+        <p:txBody>
+          <a:bodyPr/>
+          <a:p/>
+        </p:txBody>
       </p:sp>
       <p:sp>
         <p:nvSpPr>
@@ -18024,6 +18780,10 @@
             <a:prstDash val="solid"/>
           </a:ln>
         </p:spPr>
+        <p:txBody>
+          <a:bodyPr/>
+          <a:p/>
+        </p:txBody>
       </p:sp>
       <p:pic>
         <p:nvPicPr>
@@ -18206,6 +18966,10 @@
             <a:prstDash val="solid"/>
           </a:ln>
         </p:spPr>
+        <p:txBody>
+          <a:bodyPr/>
+          <a:p/>
+        </p:txBody>
       </p:sp>
       <p:sp>
         <p:nvSpPr>
@@ -18339,6 +19103,10 @@
             <a:prstDash val="solid"/>
           </a:ln>
         </p:spPr>
+        <p:txBody>
+          <a:bodyPr/>
+          <a:p/>
+        </p:txBody>
       </p:sp>
       <p:sp>
         <p:nvSpPr>
@@ -18478,6 +19246,10 @@
             <a:prstDash val="solid"/>
           </a:ln>
         </p:spPr>
+        <p:txBody>
+          <a:bodyPr/>
+          <a:p/>
+        </p:txBody>
       </p:sp>
       <p:sp>
         <p:nvSpPr>
@@ -18503,6 +19275,10 @@
             <a:prstDash val="solid"/>
           </a:ln>
         </p:spPr>
+        <p:txBody>
+          <a:bodyPr/>
+          <a:p/>
+        </p:txBody>
       </p:sp>
       <p:sp>
         <p:nvSpPr>
@@ -18567,6 +19343,10 @@
             <a:prstDash val="solid"/>
           </a:ln>
         </p:spPr>
+        <p:txBody>
+          <a:bodyPr/>
+          <a:p/>
+        </p:txBody>
       </p:sp>
       <p:sp>
         <p:nvSpPr>
@@ -18631,6 +19411,10 @@
             <a:prstDash val="solid"/>
           </a:ln>
         </p:spPr>
+        <p:txBody>
+          <a:bodyPr/>
+          <a:p/>
+        </p:txBody>
       </p:sp>
       <p:sp>
         <p:nvSpPr>
@@ -18695,6 +19479,10 @@
             <a:prstDash val="solid"/>
           </a:ln>
         </p:spPr>
+        <p:txBody>
+          <a:bodyPr/>
+          <a:p/>
+        </p:txBody>
       </p:sp>
       <p:sp>
         <p:nvSpPr>
@@ -18759,6 +19547,10 @@
             <a:prstDash val="solid"/>
           </a:ln>
         </p:spPr>
+        <p:txBody>
+          <a:bodyPr/>
+          <a:p/>
+        </p:txBody>
       </p:sp>
       <p:sp>
         <p:nvSpPr>
@@ -18823,6 +19615,10 @@
             <a:prstDash val="solid"/>
           </a:ln>
         </p:spPr>
+        <p:txBody>
+          <a:bodyPr/>
+          <a:p/>
+        </p:txBody>
       </p:sp>
       <p:sp>
         <p:nvSpPr>
@@ -18887,6 +19683,10 @@
             <a:prstDash val="solid"/>
           </a:ln>
         </p:spPr>
+        <p:txBody>
+          <a:bodyPr/>
+          <a:p/>
+        </p:txBody>
       </p:sp>
       <p:sp>
         <p:nvSpPr>
@@ -18951,6 +19751,10 @@
             <a:prstDash val="solid"/>
           </a:ln>
         </p:spPr>
+        <p:txBody>
+          <a:bodyPr/>
+          <a:p/>
+        </p:txBody>
       </p:sp>
       <p:sp>
         <p:nvSpPr>
@@ -19015,6 +19819,10 @@
             <a:prstDash val="solid"/>
           </a:ln>
         </p:spPr>
+        <p:txBody>
+          <a:bodyPr/>
+          <a:p/>
+        </p:txBody>
       </p:sp>
       <p:sp>
         <p:nvSpPr>
@@ -19079,6 +19887,10 @@
             <a:prstDash val="solid"/>
           </a:ln>
         </p:spPr>
+        <p:txBody>
+          <a:bodyPr/>
+          <a:p/>
+        </p:txBody>
       </p:sp>
       <p:sp>
         <p:nvSpPr>
@@ -19143,6 +19955,10 @@
             <a:prstDash val="solid"/>
           </a:ln>
         </p:spPr>
+        <p:txBody>
+          <a:bodyPr/>
+          <a:p/>
+        </p:txBody>
       </p:sp>
       <p:sp>
         <p:nvSpPr>
@@ -19207,6 +20023,10 @@
             <a:prstDash val="solid"/>
           </a:ln>
         </p:spPr>
+        <p:txBody>
+          <a:bodyPr/>
+          <a:p/>
+        </p:txBody>
       </p:sp>
       <p:sp>
         <p:nvSpPr>
@@ -19271,6 +20091,10 @@
             <a:prstDash val="solid"/>
           </a:ln>
         </p:spPr>
+        <p:txBody>
+          <a:bodyPr/>
+          <a:p/>
+        </p:txBody>
       </p:sp>
       <p:sp>
         <p:nvSpPr>
@@ -19335,6 +20159,10 @@
             <a:prstDash val="solid"/>
           </a:ln>
         </p:spPr>
+        <p:txBody>
+          <a:bodyPr/>
+          <a:p/>
+        </p:txBody>
       </p:sp>
       <p:sp>
         <p:nvSpPr>
@@ -19399,6 +20227,10 @@
             <a:prstDash val="solid"/>
           </a:ln>
         </p:spPr>
+        <p:txBody>
+          <a:bodyPr/>
+          <a:p/>
+        </p:txBody>
       </p:sp>
       <p:sp>
         <p:nvSpPr>
@@ -19463,6 +20295,10 @@
             <a:prstDash val="solid"/>
           </a:ln>
         </p:spPr>
+        <p:txBody>
+          <a:bodyPr/>
+          <a:p/>
+        </p:txBody>
       </p:sp>
       <p:sp>
         <p:nvSpPr>
@@ -19527,6 +20363,10 @@
             <a:prstDash val="solid"/>
           </a:ln>
         </p:spPr>
+        <p:txBody>
+          <a:bodyPr/>
+          <a:p/>
+        </p:txBody>
       </p:sp>
       <p:sp>
         <p:nvSpPr>
@@ -19591,6 +20431,10 @@
             <a:prstDash val="solid"/>
           </a:ln>
         </p:spPr>
+        <p:txBody>
+          <a:bodyPr/>
+          <a:p/>
+        </p:txBody>
       </p:sp>
       <p:sp>
         <p:nvSpPr>
@@ -19655,6 +20499,10 @@
             <a:prstDash val="solid"/>
           </a:ln>
         </p:spPr>
+        <p:txBody>
+          <a:bodyPr/>
+          <a:p/>
+        </p:txBody>
       </p:sp>
       <p:sp>
         <p:nvSpPr>
@@ -19719,6 +20567,10 @@
             <a:prstDash val="solid"/>
           </a:ln>
         </p:spPr>
+        <p:txBody>
+          <a:bodyPr/>
+          <a:p/>
+        </p:txBody>
       </p:sp>
       <p:sp>
         <p:nvSpPr>
@@ -19783,6 +20635,10 @@
             <a:prstDash val="solid"/>
           </a:ln>
         </p:spPr>
+        <p:txBody>
+          <a:bodyPr/>
+          <a:p/>
+        </p:txBody>
       </p:sp>
       <p:sp>
         <p:nvSpPr>
@@ -19847,6 +20703,10 @@
             <a:prstDash val="solid"/>
           </a:ln>
         </p:spPr>
+        <p:txBody>
+          <a:bodyPr/>
+          <a:p/>
+        </p:txBody>
       </p:sp>
       <p:sp>
         <p:nvSpPr>
@@ -19911,6 +20771,10 @@
             <a:prstDash val="solid"/>
           </a:ln>
         </p:spPr>
+        <p:txBody>
+          <a:bodyPr/>
+          <a:p/>
+        </p:txBody>
       </p:sp>
       <p:sp>
         <p:nvSpPr>
@@ -19975,6 +20839,10 @@
             <a:prstDash val="solid"/>
           </a:ln>
         </p:spPr>
+        <p:txBody>
+          <a:bodyPr/>
+          <a:p/>
+        </p:txBody>
       </p:sp>
       <p:sp>
         <p:nvSpPr>
@@ -20039,6 +20907,10 @@
             <a:prstDash val="solid"/>
           </a:ln>
         </p:spPr>
+        <p:txBody>
+          <a:bodyPr/>
+          <a:p/>
+        </p:txBody>
       </p:sp>
       <p:sp>
         <p:nvSpPr>
@@ -20103,6 +20975,10 @@
             <a:prstDash val="solid"/>
           </a:ln>
         </p:spPr>
+        <p:txBody>
+          <a:bodyPr/>
+          <a:p/>
+        </p:txBody>
       </p:sp>
       <p:sp>
         <p:nvSpPr>
@@ -20167,6 +21043,10 @@
             <a:prstDash val="solid"/>
           </a:ln>
         </p:spPr>
+        <p:txBody>
+          <a:bodyPr/>
+          <a:p/>
+        </p:txBody>
       </p:sp>
       <p:sp>
         <p:nvSpPr>
@@ -20231,6 +21111,10 @@
             <a:prstDash val="solid"/>
           </a:ln>
         </p:spPr>
+        <p:txBody>
+          <a:bodyPr/>
+          <a:p/>
+        </p:txBody>
       </p:sp>
       <p:sp>
         <p:nvSpPr>
@@ -20295,6 +21179,10 @@
             <a:prstDash val="solid"/>
           </a:ln>
         </p:spPr>
+        <p:txBody>
+          <a:bodyPr/>
+          <a:p/>
+        </p:txBody>
       </p:sp>
       <p:sp>
         <p:nvSpPr>
@@ -20359,6 +21247,10 @@
             <a:prstDash val="solid"/>
           </a:ln>
         </p:spPr>
+        <p:txBody>
+          <a:bodyPr/>
+          <a:p/>
+        </p:txBody>
       </p:sp>
       <p:sp>
         <p:nvSpPr>
@@ -20423,6 +21315,10 @@
             <a:prstDash val="solid"/>
           </a:ln>
         </p:spPr>
+        <p:txBody>
+          <a:bodyPr/>
+          <a:p/>
+        </p:txBody>
       </p:sp>
       <p:sp>
         <p:nvSpPr>
@@ -20487,6 +21383,10 @@
             <a:prstDash val="solid"/>
           </a:ln>
         </p:spPr>
+        <p:txBody>
+          <a:bodyPr/>
+          <a:p/>
+        </p:txBody>
       </p:sp>
       <p:sp>
         <p:nvSpPr>
@@ -20551,6 +21451,10 @@
             <a:prstDash val="solid"/>
           </a:ln>
         </p:spPr>
+        <p:txBody>
+          <a:bodyPr/>
+          <a:p/>
+        </p:txBody>
       </p:sp>
       <p:sp>
         <p:nvSpPr>
@@ -20615,6 +21519,10 @@
             <a:prstDash val="solid"/>
           </a:ln>
         </p:spPr>
+        <p:txBody>
+          <a:bodyPr/>
+          <a:p/>
+        </p:txBody>
       </p:sp>
       <p:sp>
         <p:nvSpPr>
@@ -20679,6 +21587,10 @@
             <a:prstDash val="solid"/>
           </a:ln>
         </p:spPr>
+        <p:txBody>
+          <a:bodyPr/>
+          <a:p/>
+        </p:txBody>
       </p:sp>
       <p:sp>
         <p:nvSpPr>
@@ -20743,6 +21655,10 @@
             <a:prstDash val="solid"/>
           </a:ln>
         </p:spPr>
+        <p:txBody>
+          <a:bodyPr/>
+          <a:p/>
+        </p:txBody>
       </p:sp>
       <p:sp>
         <p:nvSpPr>
@@ -20807,6 +21723,10 @@
             <a:prstDash val="solid"/>
           </a:ln>
         </p:spPr>
+        <p:txBody>
+          <a:bodyPr/>
+          <a:p/>
+        </p:txBody>
       </p:sp>
       <p:sp>
         <p:nvSpPr>
@@ -20871,6 +21791,10 @@
             <a:prstDash val="solid"/>
           </a:ln>
         </p:spPr>
+        <p:txBody>
+          <a:bodyPr/>
+          <a:p/>
+        </p:txBody>
       </p:sp>
       <p:sp>
         <p:nvSpPr>
@@ -20935,6 +21859,10 @@
             <a:prstDash val="solid"/>
           </a:ln>
         </p:spPr>
+        <p:txBody>
+          <a:bodyPr/>
+          <a:p/>
+        </p:txBody>
       </p:sp>
       <p:sp>
         <p:nvSpPr>
@@ -20999,6 +21927,10 @@
             <a:prstDash val="solid"/>
           </a:ln>
         </p:spPr>
+        <p:txBody>
+          <a:bodyPr/>
+          <a:p/>
+        </p:txBody>
       </p:sp>
       <p:sp>
         <p:nvSpPr>
@@ -21063,6 +21995,10 @@
             <a:prstDash val="solid"/>
           </a:ln>
         </p:spPr>
+        <p:txBody>
+          <a:bodyPr/>
+          <a:p/>
+        </p:txBody>
       </p:sp>
       <p:sp>
         <p:nvSpPr>
@@ -21127,6 +22063,10 @@
             <a:prstDash val="solid"/>
           </a:ln>
         </p:spPr>
+        <p:txBody>
+          <a:bodyPr/>
+          <a:p/>
+        </p:txBody>
       </p:sp>
       <p:sp>
         <p:nvSpPr>
@@ -21191,6 +22131,10 @@
             <a:prstDash val="solid"/>
           </a:ln>
         </p:spPr>
+        <p:txBody>
+          <a:bodyPr/>
+          <a:p/>
+        </p:txBody>
       </p:sp>
       <p:pic>
         <p:nvPicPr>
@@ -21398,6 +22342,10 @@
             <a:prstDash val="solid"/>
           </a:ln>
         </p:spPr>
+        <p:txBody>
+          <a:bodyPr/>
+          <a:p/>
+        </p:txBody>
       </p:sp>
       <p:sp>
         <p:nvSpPr>
@@ -21537,6 +22485,10 @@
             <a:prstDash val="solid"/>
           </a:ln>
         </p:spPr>
+        <p:txBody>
+          <a:bodyPr/>
+          <a:p/>
+        </p:txBody>
       </p:sp>
       <p:sp>
         <p:nvSpPr>
@@ -21562,6 +22514,10 @@
             <a:prstDash val="solid"/>
           </a:ln>
         </p:spPr>
+        <p:txBody>
+          <a:bodyPr/>
+          <a:p/>
+        </p:txBody>
       </p:sp>
       <p:sp>
         <p:nvSpPr>
@@ -21587,6 +22543,10 @@
             <a:prstDash val="solid"/>
           </a:ln>
         </p:spPr>
+        <p:txBody>
+          <a:bodyPr/>
+          <a:p/>
+        </p:txBody>
       </p:sp>
       <p:sp>
         <p:nvSpPr>
@@ -21729,6 +22689,10 @@
             <a:prstDash val="solid"/>
           </a:ln>
         </p:spPr>
+        <p:txBody>
+          <a:bodyPr/>
+          <a:p/>
+        </p:txBody>
       </p:sp>
       <p:sp>
         <p:nvSpPr>
@@ -21754,6 +22718,10 @@
             <a:prstDash val="solid"/>
           </a:ln>
         </p:spPr>
+        <p:txBody>
+          <a:bodyPr/>
+          <a:p/>
+        </p:txBody>
       </p:sp>
       <p:sp>
         <p:nvSpPr>
@@ -21896,6 +22864,10 @@
             <a:prstDash val="solid"/>
           </a:ln>
         </p:spPr>
+        <p:txBody>
+          <a:bodyPr/>
+          <a:p/>
+        </p:txBody>
       </p:sp>
       <p:sp>
         <p:nvSpPr>
@@ -21921,6 +22893,10 @@
             <a:prstDash val="solid"/>
           </a:ln>
         </p:spPr>
+        <p:txBody>
+          <a:bodyPr/>
+          <a:p/>
+        </p:txBody>
       </p:sp>
       <p:sp>
         <p:nvSpPr>
@@ -22063,6 +23039,10 @@
             <a:prstDash val="solid"/>
           </a:ln>
         </p:spPr>
+        <p:txBody>
+          <a:bodyPr/>
+          <a:p/>
+        </p:txBody>
       </p:sp>
       <p:sp>
         <p:nvSpPr>
@@ -22127,6 +23107,10 @@
             <a:prstDash val="solid"/>
           </a:ln>
         </p:spPr>
+        <p:txBody>
+          <a:bodyPr/>
+          <a:p/>
+        </p:txBody>
       </p:sp>
       <p:sp>
         <p:nvSpPr>
@@ -22191,6 +23175,10 @@
             <a:prstDash val="solid"/>
           </a:ln>
         </p:spPr>
+        <p:txBody>
+          <a:bodyPr/>
+          <a:p/>
+        </p:txBody>
       </p:sp>
       <p:sp>
         <p:nvSpPr>
@@ -22255,6 +23243,10 @@
             <a:prstDash val="solid"/>
           </a:ln>
         </p:spPr>
+        <p:txBody>
+          <a:bodyPr/>
+          <a:p/>
+        </p:txBody>
       </p:sp>
       <p:sp>
         <p:nvSpPr>
@@ -22319,6 +23311,10 @@
             <a:prstDash val="solid"/>
           </a:ln>
         </p:spPr>
+        <p:txBody>
+          <a:bodyPr/>
+          <a:p/>
+        </p:txBody>
       </p:sp>
       <p:sp>
         <p:nvSpPr>
@@ -22383,6 +23379,10 @@
             <a:prstDash val="solid"/>
           </a:ln>
         </p:spPr>
+        <p:txBody>
+          <a:bodyPr/>
+          <a:p/>
+        </p:txBody>
       </p:sp>
       <p:sp>
         <p:nvSpPr>
@@ -22447,6 +23447,10 @@
             <a:prstDash val="solid"/>
           </a:ln>
         </p:spPr>
+        <p:txBody>
+          <a:bodyPr/>
+          <a:p/>
+        </p:txBody>
       </p:sp>
       <p:sp>
         <p:nvSpPr>
@@ -22511,6 +23515,10 @@
             <a:prstDash val="solid"/>
           </a:ln>
         </p:spPr>
+        <p:txBody>
+          <a:bodyPr/>
+          <a:p/>
+        </p:txBody>
       </p:sp>
       <p:sp>
         <p:nvSpPr>
@@ -22575,6 +23583,10 @@
             <a:prstDash val="solid"/>
           </a:ln>
         </p:spPr>
+        <p:txBody>
+          <a:bodyPr/>
+          <a:p/>
+        </p:txBody>
       </p:sp>
       <p:sp>
         <p:nvSpPr>
@@ -22639,6 +23651,10 @@
             <a:prstDash val="solid"/>
           </a:ln>
         </p:spPr>
+        <p:txBody>
+          <a:bodyPr/>
+          <a:p/>
+        </p:txBody>
       </p:sp>
       <p:sp>
         <p:nvSpPr>
@@ -22703,6 +23719,10 @@
             <a:prstDash val="solid"/>
           </a:ln>
         </p:spPr>
+        <p:txBody>
+          <a:bodyPr/>
+          <a:p/>
+        </p:txBody>
       </p:sp>
       <p:sp>
         <p:nvSpPr>
@@ -22767,6 +23787,10 @@
             <a:prstDash val="solid"/>
           </a:ln>
         </p:spPr>
+        <p:txBody>
+          <a:bodyPr/>
+          <a:p/>
+        </p:txBody>
       </p:sp>
       <p:sp>
         <p:nvSpPr>
@@ -22831,6 +23855,10 @@
             <a:prstDash val="solid"/>
           </a:ln>
         </p:spPr>
+        <p:txBody>
+          <a:bodyPr/>
+          <a:p/>
+        </p:txBody>
       </p:sp>
       <p:sp>
         <p:nvSpPr>
@@ -22895,6 +23923,10 @@
             <a:prstDash val="solid"/>
           </a:ln>
         </p:spPr>
+        <p:txBody>
+          <a:bodyPr/>
+          <a:p/>
+        </p:txBody>
       </p:sp>
       <p:sp>
         <p:nvSpPr>
@@ -22959,6 +23991,10 @@
             <a:prstDash val="solid"/>
           </a:ln>
         </p:spPr>
+        <p:txBody>
+          <a:bodyPr/>
+          <a:p/>
+        </p:txBody>
       </p:sp>
       <p:sp>
         <p:nvSpPr>
@@ -23023,6 +24059,10 @@
             <a:prstDash val="solid"/>
           </a:ln>
         </p:spPr>
+        <p:txBody>
+          <a:bodyPr/>
+          <a:p/>
+        </p:txBody>
       </p:sp>
       <p:sp>
         <p:nvSpPr>
@@ -23087,6 +24127,10 @@
             <a:prstDash val="solid"/>
           </a:ln>
         </p:spPr>
+        <p:txBody>
+          <a:bodyPr/>
+          <a:p/>
+        </p:txBody>
       </p:sp>
       <p:sp>
         <p:nvSpPr>
@@ -23151,6 +24195,10 @@
             <a:prstDash val="solid"/>
           </a:ln>
         </p:spPr>
+        <p:txBody>
+          <a:bodyPr/>
+          <a:p/>
+        </p:txBody>
       </p:sp>
       <p:sp>
         <p:nvSpPr>
@@ -23215,6 +24263,10 @@
             <a:prstDash val="solid"/>
           </a:ln>
         </p:spPr>
+        <p:txBody>
+          <a:bodyPr/>
+          <a:p/>
+        </p:txBody>
       </p:sp>
       <p:sp>
         <p:nvSpPr>
@@ -23249,7 +24301,7 @@
                 <a:ea typeface="Calibri" pitchFamily="34" charset="-122"/>
                 <a:cs typeface="Calibri" pitchFamily="34" charset="-120"/>
               </a:rPr>
-              <a:t>7,329</a:t>
+              <a:t>4,385</a:t>
             </a:r>
             <a:endParaRPr lang="en-US" sz="900" dirty="0"/>
           </a:p>
@@ -23279,6 +24331,10 @@
             <a:prstDash val="solid"/>
           </a:ln>
         </p:spPr>
+        <p:txBody>
+          <a:bodyPr/>
+          <a:p/>
+        </p:txBody>
       </p:sp>
       <p:sp>
         <p:nvSpPr>
@@ -23343,6 +24399,10 @@
             <a:prstDash val="solid"/>
           </a:ln>
         </p:spPr>
+        <p:txBody>
+          <a:bodyPr/>
+          <a:p/>
+        </p:txBody>
       </p:sp>
       <p:sp>
         <p:nvSpPr>
@@ -23407,6 +24467,10 @@
             <a:prstDash val="solid"/>
           </a:ln>
         </p:spPr>
+        <p:txBody>
+          <a:bodyPr/>
+          <a:p/>
+        </p:txBody>
       </p:sp>
       <p:sp>
         <p:nvSpPr>
@@ -23471,6 +24535,10 @@
             <a:prstDash val="solid"/>
           </a:ln>
         </p:spPr>
+        <p:txBody>
+          <a:bodyPr/>
+          <a:p/>
+        </p:txBody>
       </p:sp>
       <p:sp>
         <p:nvSpPr>
@@ -23535,6 +24603,10 @@
             <a:prstDash val="solid"/>
           </a:ln>
         </p:spPr>
+        <p:txBody>
+          <a:bodyPr/>
+          <a:p/>
+        </p:txBody>
       </p:sp>
       <p:sp>
         <p:nvSpPr>
@@ -23599,6 +24671,10 @@
             <a:prstDash val="solid"/>
           </a:ln>
         </p:spPr>
+        <p:txBody>
+          <a:bodyPr/>
+          <a:p/>
+        </p:txBody>
       </p:sp>
       <p:sp>
         <p:nvSpPr>
@@ -23702,6 +24778,10 @@
             <a:prstDash val="solid"/>
           </a:ln>
         </p:spPr>
+        <p:txBody>
+          <a:bodyPr/>
+          <a:p/>
+        </p:txBody>
       </p:sp>
       <p:sp>
         <p:nvSpPr>
@@ -23766,6 +24846,10 @@
             <a:prstDash val="solid"/>
           </a:ln>
         </p:spPr>
+        <p:txBody>
+          <a:bodyPr/>
+          <a:p/>
+        </p:txBody>
       </p:sp>
       <p:sp>
         <p:nvSpPr>
@@ -23791,6 +24875,10 @@
             <a:prstDash val="solid"/>
           </a:ln>
         </p:spPr>
+        <p:txBody>
+          <a:bodyPr/>
+          <a:p/>
+        </p:txBody>
       </p:sp>
       <p:sp>
         <p:nvSpPr>
@@ -23950,6 +25038,10 @@
             <a:prstDash val="solid"/>
           </a:ln>
         </p:spPr>
+        <p:txBody>
+          <a:bodyPr/>
+          <a:p/>
+        </p:txBody>
       </p:sp>
       <p:sp>
         <p:nvSpPr>
@@ -23975,6 +25067,10 @@
             <a:prstDash val="solid"/>
           </a:ln>
         </p:spPr>
+        <p:txBody>
+          <a:bodyPr/>
+          <a:p/>
+        </p:txBody>
       </p:sp>
       <p:sp>
         <p:nvSpPr>
@@ -24134,6 +25230,10 @@
             <a:prstDash val="solid"/>
           </a:ln>
         </p:spPr>
+        <p:txBody>
+          <a:bodyPr/>
+          <a:p/>
+        </p:txBody>
       </p:sp>
       <p:sp>
         <p:nvSpPr>
@@ -24159,6 +25259,10 @@
             <a:prstDash val="solid"/>
           </a:ln>
         </p:spPr>
+        <p:txBody>
+          <a:bodyPr/>
+          <a:p/>
+        </p:txBody>
       </p:sp>
       <p:sp>
         <p:nvSpPr>
@@ -24426,6 +25530,10 @@
             <a:prstDash val="solid"/>
           </a:ln>
         </p:spPr>
+        <p:txBody>
+          <a:bodyPr/>
+          <a:p/>
+        </p:txBody>
       </p:sp>
       <p:sp>
         <p:nvSpPr>
@@ -24535,7 +25643,7 @@
                 <a:ea typeface="Calibri" pitchFamily="34" charset="-122"/>
                 <a:cs typeface="Calibri" pitchFamily="34" charset="-120"/>
               </a:rPr>
-              <a:t>Monte Carlo N=200 per scenario — Sylhet parameterised conditions</a:t>
+              <a:t>Monte Carlo N=30 — Sylhet parameterised conditions</a:t>
             </a:r>
             <a:endParaRPr lang="en-US" sz="1250" dirty="0"/>
           </a:p>
@@ -24565,6 +25673,10 @@
             <a:prstDash val="solid"/>
           </a:ln>
         </p:spPr>
+        <p:txBody>
+          <a:bodyPr/>
+          <a:p/>
+        </p:txBody>
       </p:sp>
       <p:sp>
         <p:nvSpPr>
@@ -24590,6 +25702,10 @@
             <a:prstDash val="solid"/>
           </a:ln>
         </p:spPr>
+        <p:txBody>
+          <a:bodyPr/>
+          <a:p/>
+        </p:txBody>
       </p:sp>
       <p:sp>
         <p:nvSpPr>
@@ -24615,6 +25731,10 @@
             <a:prstDash val="solid"/>
           </a:ln>
         </p:spPr>
+        <p:txBody>
+          <a:bodyPr/>
+          <a:p/>
+        </p:txBody>
       </p:sp>
       <p:sp>
         <p:nvSpPr>
@@ -24757,6 +25877,10 @@
             <a:prstDash val="solid"/>
           </a:ln>
         </p:spPr>
+        <p:txBody>
+          <a:bodyPr/>
+          <a:p/>
+        </p:txBody>
       </p:sp>
       <p:sp>
         <p:nvSpPr>
@@ -24782,6 +25906,10 @@
             <a:prstDash val="solid"/>
           </a:ln>
         </p:spPr>
+        <p:txBody>
+          <a:bodyPr/>
+          <a:p/>
+        </p:txBody>
       </p:sp>
       <p:sp>
         <p:nvSpPr>
@@ -24924,6 +26052,10 @@
             <a:prstDash val="solid"/>
           </a:ln>
         </p:spPr>
+        <p:txBody>
+          <a:bodyPr/>
+          <a:p/>
+        </p:txBody>
       </p:sp>
       <p:sp>
         <p:nvSpPr>
@@ -24949,6 +26081,10 @@
             <a:prstDash val="solid"/>
           </a:ln>
         </p:spPr>
+        <p:txBody>
+          <a:bodyPr/>
+          <a:p/>
+        </p:txBody>
       </p:sp>
       <p:sp>
         <p:nvSpPr>
@@ -25091,6 +26227,10 @@
             <a:prstDash val="solid"/>
           </a:ln>
         </p:spPr>
+        <p:txBody>
+          <a:bodyPr/>
+          <a:p/>
+        </p:txBody>
       </p:sp>
       <p:sp>
         <p:nvSpPr>
@@ -25116,6 +26256,10 @@
             <a:prstDash val="solid"/>
           </a:ln>
         </p:spPr>
+        <p:txBody>
+          <a:bodyPr/>
+          <a:p/>
+        </p:txBody>
       </p:sp>
       <p:sp>
         <p:nvSpPr>
@@ -25258,6 +26402,10 @@
             <a:prstDash val="solid"/>
           </a:ln>
         </p:spPr>
+        <p:txBody>
+          <a:bodyPr/>
+          <a:p/>
+        </p:txBody>
       </p:sp>
       <p:sp>
         <p:nvSpPr>
@@ -25322,6 +26470,10 @@
             <a:prstDash val="solid"/>
           </a:ln>
         </p:spPr>
+        <p:txBody>
+          <a:bodyPr/>
+          <a:p/>
+        </p:txBody>
       </p:sp>
       <p:sp>
         <p:nvSpPr>
@@ -25386,6 +26538,10 @@
             <a:prstDash val="solid"/>
           </a:ln>
         </p:spPr>
+        <p:txBody>
+          <a:bodyPr/>
+          <a:p/>
+        </p:txBody>
       </p:sp>
       <p:sp>
         <p:nvSpPr>
@@ -25450,6 +26606,10 @@
             <a:prstDash val="solid"/>
           </a:ln>
         </p:spPr>
+        <p:txBody>
+          <a:bodyPr/>
+          <a:p/>
+        </p:txBody>
       </p:sp>
       <p:sp>
         <p:nvSpPr>
@@ -25514,6 +26674,10 @@
             <a:prstDash val="solid"/>
           </a:ln>
         </p:spPr>
+        <p:txBody>
+          <a:bodyPr/>
+          <a:p/>
+        </p:txBody>
       </p:sp>
       <p:sp>
         <p:nvSpPr>
@@ -25578,6 +26742,10 @@
             <a:prstDash val="solid"/>
           </a:ln>
         </p:spPr>
+        <p:txBody>
+          <a:bodyPr/>
+          <a:p/>
+        </p:txBody>
       </p:sp>
       <p:sp>
         <p:nvSpPr>
@@ -25642,6 +26810,10 @@
             <a:prstDash val="solid"/>
           </a:ln>
         </p:spPr>
+        <p:txBody>
+          <a:bodyPr/>
+          <a:p/>
+        </p:txBody>
       </p:sp>
       <p:sp>
         <p:nvSpPr>
@@ -25706,6 +26878,10 @@
             <a:prstDash val="solid"/>
           </a:ln>
         </p:spPr>
+        <p:txBody>
+          <a:bodyPr/>
+          <a:p/>
+        </p:txBody>
       </p:sp>
       <p:sp>
         <p:nvSpPr>
@@ -25770,6 +26946,10 @@
             <a:prstDash val="solid"/>
           </a:ln>
         </p:spPr>
+        <p:txBody>
+          <a:bodyPr/>
+          <a:p/>
+        </p:txBody>
       </p:sp>
       <p:sp>
         <p:nvSpPr>
@@ -25834,6 +27014,10 @@
             <a:prstDash val="solid"/>
           </a:ln>
         </p:spPr>
+        <p:txBody>
+          <a:bodyPr/>
+          <a:p/>
+        </p:txBody>
       </p:sp>
       <p:sp>
         <p:nvSpPr>
@@ -25898,6 +27082,10 @@
             <a:prstDash val="solid"/>
           </a:ln>
         </p:spPr>
+        <p:txBody>
+          <a:bodyPr/>
+          <a:p/>
+        </p:txBody>
       </p:sp>
       <p:sp>
         <p:nvSpPr>
@@ -25962,6 +27150,10 @@
             <a:prstDash val="solid"/>
           </a:ln>
         </p:spPr>
+        <p:txBody>
+          <a:bodyPr/>
+          <a:p/>
+        </p:txBody>
       </p:sp>
       <p:sp>
         <p:nvSpPr>
@@ -26026,6 +27218,10 @@
             <a:prstDash val="solid"/>
           </a:ln>
         </p:spPr>
+        <p:txBody>
+          <a:bodyPr/>
+          <a:p/>
+        </p:txBody>
       </p:sp>
       <p:sp>
         <p:nvSpPr>
@@ -26090,6 +27286,10 @@
             <a:prstDash val="solid"/>
           </a:ln>
         </p:spPr>
+        <p:txBody>
+          <a:bodyPr/>
+          <a:p/>
+        </p:txBody>
       </p:sp>
       <p:sp>
         <p:nvSpPr>
@@ -26154,6 +27354,10 @@
             <a:prstDash val="solid"/>
           </a:ln>
         </p:spPr>
+        <p:txBody>
+          <a:bodyPr/>
+          <a:p/>
+        </p:txBody>
       </p:sp>
       <p:sp>
         <p:nvSpPr>
@@ -26218,6 +27422,10 @@
             <a:prstDash val="solid"/>
           </a:ln>
         </p:spPr>
+        <p:txBody>
+          <a:bodyPr/>
+          <a:p/>
+        </p:txBody>
       </p:sp>
       <p:sp>
         <p:nvSpPr>
@@ -26282,6 +27490,10 @@
             <a:prstDash val="solid"/>
           </a:ln>
         </p:spPr>
+        <p:txBody>
+          <a:bodyPr/>
+          <a:p/>
+        </p:txBody>
       </p:sp>
       <p:sp>
         <p:nvSpPr>
@@ -26346,6 +27558,10 @@
             <a:prstDash val="solid"/>
           </a:ln>
         </p:spPr>
+        <p:txBody>
+          <a:bodyPr/>
+          <a:p/>
+        </p:txBody>
       </p:sp>
       <p:sp>
         <p:nvSpPr>
@@ -26410,6 +27626,10 @@
             <a:prstDash val="solid"/>
           </a:ln>
         </p:spPr>
+        <p:txBody>
+          <a:bodyPr/>
+          <a:p/>
+        </p:txBody>
       </p:sp>
       <p:sp>
         <p:nvSpPr>
@@ -26474,6 +27694,10 @@
             <a:prstDash val="solid"/>
           </a:ln>
         </p:spPr>
+        <p:txBody>
+          <a:bodyPr/>
+          <a:p/>
+        </p:txBody>
       </p:sp>
       <p:sp>
         <p:nvSpPr>
@@ -26538,6 +27762,10 @@
             <a:prstDash val="solid"/>
           </a:ln>
         </p:spPr>
+        <p:txBody>
+          <a:bodyPr/>
+          <a:p/>
+        </p:txBody>
       </p:sp>
       <p:sp>
         <p:nvSpPr>
@@ -26602,6 +27830,10 @@
             <a:prstDash val="solid"/>
           </a:ln>
         </p:spPr>
+        <p:txBody>
+          <a:bodyPr/>
+          <a:p/>
+        </p:txBody>
       </p:sp>
       <p:sp>
         <p:nvSpPr>
@@ -26666,6 +27898,10 @@
             <a:prstDash val="solid"/>
           </a:ln>
         </p:spPr>
+        <p:txBody>
+          <a:bodyPr/>
+          <a:p/>
+        </p:txBody>
       </p:sp>
       <p:sp>
         <p:nvSpPr>
@@ -26730,6 +27966,10 @@
             <a:prstDash val="solid"/>
           </a:ln>
         </p:spPr>
+        <p:txBody>
+          <a:bodyPr/>
+          <a:p/>
+        </p:txBody>
       </p:sp>
       <p:sp>
         <p:nvSpPr>
@@ -26794,6 +28034,10 @@
             <a:prstDash val="solid"/>
           </a:ln>
         </p:spPr>
+        <p:txBody>
+          <a:bodyPr/>
+          <a:p/>
+        </p:txBody>
       </p:sp>
       <p:sp>
         <p:nvSpPr>
@@ -26858,6 +28102,10 @@
             <a:prstDash val="solid"/>
           </a:ln>
         </p:spPr>
+        <p:txBody>
+          <a:bodyPr/>
+          <a:p/>
+        </p:txBody>
       </p:sp>
       <p:sp>
         <p:nvSpPr>
@@ -26922,6 +28170,10 @@
             <a:prstDash val="solid"/>
           </a:ln>
         </p:spPr>
+        <p:txBody>
+          <a:bodyPr/>
+          <a:p/>
+        </p:txBody>
       </p:sp>
       <p:sp>
         <p:nvSpPr>
@@ -26986,6 +28238,10 @@
             <a:prstDash val="solid"/>
           </a:ln>
         </p:spPr>
+        <p:txBody>
+          <a:bodyPr/>
+          <a:p/>
+        </p:txBody>
       </p:sp>
       <p:sp>
         <p:nvSpPr>
@@ -27050,6 +28306,10 @@
             <a:prstDash val="solid"/>
           </a:ln>
         </p:spPr>
+        <p:txBody>
+          <a:bodyPr/>
+          <a:p/>
+        </p:txBody>
       </p:sp>
       <p:sp>
         <p:nvSpPr>
@@ -27114,6 +28374,10 @@
             <a:prstDash val="solid"/>
           </a:ln>
         </p:spPr>
+        <p:txBody>
+          <a:bodyPr/>
+          <a:p/>
+        </p:txBody>
       </p:sp>
       <p:sp>
         <p:nvSpPr>
@@ -27178,6 +28442,10 @@
             <a:prstDash val="solid"/>
           </a:ln>
         </p:spPr>
+        <p:txBody>
+          <a:bodyPr/>
+          <a:p/>
+        </p:txBody>
       </p:sp>
       <p:sp>
         <p:nvSpPr>

</xml_diff>